<commit_message>
Inicio del curso 26/27
</commit_message>
<xml_diff>
--- a/pdfs/Arquitectura de Computadores.pptx
+++ b/pdfs/Arquitectura de Computadores.pptx
@@ -10,8 +10,10 @@
     <p:sldId id="259" r:id="rId7"/>
     <p:sldId id="258" r:id="rId8"/>
     <p:sldId id="264" r:id="rId9"/>
-    <p:sldId id="260" r:id="rId10"/>
-    <p:sldId id="262" r:id="rId11"/>
+    <p:sldId id="266" r:id="rId10"/>
+    <p:sldId id="265" r:id="rId11"/>
+    <p:sldId id="260" r:id="rId12"/>
+    <p:sldId id="262" r:id="rId13"/>
   </p:sldIdLst>
   <p:sldSz cx="9144000" cy="6858000" type="screen4x3"/>
   <p:notesSz cx="6858000" cy="9144000"/>
@@ -129,12 +131,155 @@
 </p:presentation>
 </file>
 
-<file path=ppt/revisionInfo.xml><?xml version="1.0" encoding="utf-8"?>
-<p1510:revInfo xmlns:a="http://schemas.openxmlformats.org/drawingml/2006/main" xmlns:r="http://schemas.openxmlformats.org/officeDocument/2006/relationships" xmlns:p1510="http://schemas.microsoft.com/office/powerpoint/2015/10/main">
-  <p1510:revLst>
-    <p1510:client id="{E5657EC0-C985-47B8-BEE9-ED4F3817724A}" v="42" dt="2019-10-02T07:19:02.419"/>
-  </p1510:revLst>
-</p1510:revInfo>
+<file path=ppt/changesInfos/changesInfo1.xml><?xml version="1.0" encoding="utf-8"?>
+<pc:chgInfo xmlns:a="http://schemas.openxmlformats.org/drawingml/2006/main" xmlns:r="http://schemas.openxmlformats.org/officeDocument/2006/relationships" xmlns:ac="http://schemas.microsoft.com/office/drawing/2013/main/command" xmlns:pc="http://schemas.microsoft.com/office/powerpoint/2013/main/command">
+  <pc:docChgLst>
+    <pc:chgData name="Luis Felipe Romero" userId="a68c3b35-3f81-40e2-b356-0db0b132b71b" providerId="ADAL" clId="{7E6696D6-E27B-453E-8512-AD5D6829E589}"/>
+    <pc:docChg chg="custSel addSld modSld">
+      <pc:chgData name="Luis Felipe Romero" userId="a68c3b35-3f81-40e2-b356-0db0b132b71b" providerId="ADAL" clId="{7E6696D6-E27B-453E-8512-AD5D6829E589}" dt="2026-09-10T06:54:27.174" v="548" actId="1076"/>
+      <pc:docMkLst>
+        <pc:docMk/>
+      </pc:docMkLst>
+      <pc:sldChg chg="modSp mod">
+        <pc:chgData name="Luis Felipe Romero" userId="a68c3b35-3f81-40e2-b356-0db0b132b71b" providerId="ADAL" clId="{7E6696D6-E27B-453E-8512-AD5D6829E589}" dt="2026-09-10T06:20:31.371" v="2" actId="20577"/>
+        <pc:sldMkLst>
+          <pc:docMk/>
+          <pc:sldMk cId="3420325496" sldId="256"/>
+        </pc:sldMkLst>
+        <pc:spChg chg="mod">
+          <ac:chgData name="Luis Felipe Romero" userId="a68c3b35-3f81-40e2-b356-0db0b132b71b" providerId="ADAL" clId="{7E6696D6-E27B-453E-8512-AD5D6829E589}" dt="2026-09-10T06:20:31.371" v="2" actId="20577"/>
+          <ac:spMkLst>
+            <pc:docMk/>
+            <pc:sldMk cId="3420325496" sldId="256"/>
+            <ac:spMk id="3" creationId="{00000000-0000-0000-0000-000000000000}"/>
+          </ac:spMkLst>
+        </pc:spChg>
+      </pc:sldChg>
+      <pc:sldChg chg="addSp delSp modSp mod">
+        <pc:chgData name="Luis Felipe Romero" userId="a68c3b35-3f81-40e2-b356-0db0b132b71b" providerId="ADAL" clId="{7E6696D6-E27B-453E-8512-AD5D6829E589}" dt="2026-09-10T06:34:49.974" v="41" actId="20577"/>
+        <pc:sldMkLst>
+          <pc:docMk/>
+          <pc:sldMk cId="625546087" sldId="257"/>
+        </pc:sldMkLst>
+        <pc:spChg chg="add mod">
+          <ac:chgData name="Luis Felipe Romero" userId="a68c3b35-3f81-40e2-b356-0db0b132b71b" providerId="ADAL" clId="{7E6696D6-E27B-453E-8512-AD5D6829E589}" dt="2026-09-10T06:34:49.974" v="41" actId="20577"/>
+          <ac:spMkLst>
+            <pc:docMk/>
+            <pc:sldMk cId="625546087" sldId="257"/>
+            <ac:spMk id="5" creationId="{E2FAE8E7-3B75-42DA-8859-49B3B4D97924}"/>
+          </ac:spMkLst>
+        </pc:spChg>
+        <pc:picChg chg="del">
+          <ac:chgData name="Luis Felipe Romero" userId="a68c3b35-3f81-40e2-b356-0db0b132b71b" providerId="ADAL" clId="{7E6696D6-E27B-453E-8512-AD5D6829E589}" dt="2026-09-10T06:34:20.727" v="26" actId="478"/>
+          <ac:picMkLst>
+            <pc:docMk/>
+            <pc:sldMk cId="625546087" sldId="257"/>
+            <ac:picMk id="2" creationId="{F40CDFC2-0D01-40F1-B9F3-67C69E3E47D2}"/>
+          </ac:picMkLst>
+        </pc:picChg>
+        <pc:picChg chg="add mod">
+          <ac:chgData name="Luis Felipe Romero" userId="a68c3b35-3f81-40e2-b356-0db0b132b71b" providerId="ADAL" clId="{7E6696D6-E27B-453E-8512-AD5D6829E589}" dt="2026-09-10T06:34:29.720" v="28" actId="1076"/>
+          <ac:picMkLst>
+            <pc:docMk/>
+            <pc:sldMk cId="625546087" sldId="257"/>
+            <ac:picMk id="4" creationId="{37F48B78-60AB-497B-90C2-5C87950910E1}"/>
+          </ac:picMkLst>
+        </pc:picChg>
+      </pc:sldChg>
+      <pc:sldChg chg="addSp delSp modSp mod">
+        <pc:chgData name="Luis Felipe Romero" userId="a68c3b35-3f81-40e2-b356-0db0b132b71b" providerId="ADAL" clId="{7E6696D6-E27B-453E-8512-AD5D6829E589}" dt="2026-09-10T06:28:26.879" v="7" actId="1076"/>
+        <pc:sldMkLst>
+          <pc:docMk/>
+          <pc:sldMk cId="658904648" sldId="258"/>
+        </pc:sldMkLst>
+        <pc:picChg chg="del">
+          <ac:chgData name="Luis Felipe Romero" userId="a68c3b35-3f81-40e2-b356-0db0b132b71b" providerId="ADAL" clId="{7E6696D6-E27B-453E-8512-AD5D6829E589}" dt="2026-09-10T06:28:15.709" v="4" actId="478"/>
+          <ac:picMkLst>
+            <pc:docMk/>
+            <pc:sldMk cId="658904648" sldId="258"/>
+            <ac:picMk id="3" creationId="{6A2F4799-A950-4F1C-BC13-02D194CDD79D}"/>
+          </ac:picMkLst>
+        </pc:picChg>
+        <pc:picChg chg="add mod">
+          <ac:chgData name="Luis Felipe Romero" userId="a68c3b35-3f81-40e2-b356-0db0b132b71b" providerId="ADAL" clId="{7E6696D6-E27B-453E-8512-AD5D6829E589}" dt="2026-09-10T06:28:26.879" v="7" actId="1076"/>
+          <ac:picMkLst>
+            <pc:docMk/>
+            <pc:sldMk cId="658904648" sldId="258"/>
+            <ac:picMk id="6" creationId="{3FAE1DC8-9FB2-4AD5-A4E5-4AD5CEB3E9FB}"/>
+          </ac:picMkLst>
+        </pc:picChg>
+      </pc:sldChg>
+      <pc:sldChg chg="modSp mod">
+        <pc:chgData name="Luis Felipe Romero" userId="a68c3b35-3f81-40e2-b356-0db0b132b71b" providerId="ADAL" clId="{7E6696D6-E27B-453E-8512-AD5D6829E589}" dt="2026-09-10T06:30:18.076" v="24" actId="20577"/>
+        <pc:sldMkLst>
+          <pc:docMk/>
+          <pc:sldMk cId="3430462956" sldId="262"/>
+        </pc:sldMkLst>
+        <pc:spChg chg="mod">
+          <ac:chgData name="Luis Felipe Romero" userId="a68c3b35-3f81-40e2-b356-0db0b132b71b" providerId="ADAL" clId="{7E6696D6-E27B-453E-8512-AD5D6829E589}" dt="2026-09-10T06:30:18.076" v="24" actId="20577"/>
+          <ac:spMkLst>
+            <pc:docMk/>
+            <pc:sldMk cId="3430462956" sldId="262"/>
+            <ac:spMk id="3" creationId="{00000000-0000-0000-0000-000000000000}"/>
+          </ac:spMkLst>
+        </pc:spChg>
+      </pc:sldChg>
+      <pc:sldChg chg="modSp mod">
+        <pc:chgData name="Luis Felipe Romero" userId="a68c3b35-3f81-40e2-b356-0db0b132b71b" providerId="ADAL" clId="{7E6696D6-E27B-453E-8512-AD5D6829E589}" dt="2026-09-10T06:53:52.220" v="541" actId="1076"/>
+        <pc:sldMkLst>
+          <pc:docMk/>
+          <pc:sldMk cId="2495430306" sldId="264"/>
+        </pc:sldMkLst>
+        <pc:picChg chg="mod modCrop">
+          <ac:chgData name="Luis Felipe Romero" userId="a68c3b35-3f81-40e2-b356-0db0b132b71b" providerId="ADAL" clId="{7E6696D6-E27B-453E-8512-AD5D6829E589}" dt="2026-09-10T06:53:52.220" v="541" actId="1076"/>
+          <ac:picMkLst>
+            <pc:docMk/>
+            <pc:sldMk cId="2495430306" sldId="264"/>
+            <ac:picMk id="3" creationId="{18B6B8DE-C4D2-4FDF-BB6D-D981B0846295}"/>
+          </ac:picMkLst>
+        </pc:picChg>
+      </pc:sldChg>
+      <pc:sldChg chg="addSp modSp new mod chgLayout">
+        <pc:chgData name="Luis Felipe Romero" userId="a68c3b35-3f81-40e2-b356-0db0b132b71b" providerId="ADAL" clId="{7E6696D6-E27B-453E-8512-AD5D6829E589}" dt="2026-09-10T06:52:24.709" v="531" actId="20577"/>
+        <pc:sldMkLst>
+          <pc:docMk/>
+          <pc:sldMk cId="1495471381" sldId="265"/>
+        </pc:sldMkLst>
+        <pc:spChg chg="mod ord">
+          <ac:chgData name="Luis Felipe Romero" userId="a68c3b35-3f81-40e2-b356-0db0b132b71b" providerId="ADAL" clId="{7E6696D6-E27B-453E-8512-AD5D6829E589}" dt="2026-09-10T06:41:03.296" v="81" actId="700"/>
+          <ac:spMkLst>
+            <pc:docMk/>
+            <pc:sldMk cId="1495471381" sldId="265"/>
+            <ac:spMk id="2" creationId="{44CD1AC7-1036-4631-96D7-3915C8D3A0B3}"/>
+          </ac:spMkLst>
+        </pc:spChg>
+        <pc:spChg chg="add mod ord">
+          <ac:chgData name="Luis Felipe Romero" userId="a68c3b35-3f81-40e2-b356-0db0b132b71b" providerId="ADAL" clId="{7E6696D6-E27B-453E-8512-AD5D6829E589}" dt="2026-09-10T06:52:24.709" v="531" actId="20577"/>
+          <ac:spMkLst>
+            <pc:docMk/>
+            <pc:sldMk cId="1495471381" sldId="265"/>
+            <ac:spMk id="3" creationId="{FB128483-14E0-419D-A99C-5B612375638C}"/>
+          </ac:spMkLst>
+        </pc:spChg>
+      </pc:sldChg>
+      <pc:sldChg chg="modSp add mod">
+        <pc:chgData name="Luis Felipe Romero" userId="a68c3b35-3f81-40e2-b356-0db0b132b71b" providerId="ADAL" clId="{7E6696D6-E27B-453E-8512-AD5D6829E589}" dt="2026-09-10T06:54:27.174" v="548" actId="1076"/>
+        <pc:sldMkLst>
+          <pc:docMk/>
+          <pc:sldMk cId="4022057110" sldId="266"/>
+        </pc:sldMkLst>
+        <pc:picChg chg="mod modCrop">
+          <ac:chgData name="Luis Felipe Romero" userId="a68c3b35-3f81-40e2-b356-0db0b132b71b" providerId="ADAL" clId="{7E6696D6-E27B-453E-8512-AD5D6829E589}" dt="2026-09-10T06:54:27.174" v="548" actId="1076"/>
+          <ac:picMkLst>
+            <pc:docMk/>
+            <pc:sldMk cId="4022057110" sldId="266"/>
+            <ac:picMk id="3" creationId="{18B6B8DE-C4D2-4FDF-BB6D-D981B0846295}"/>
+          </ac:picMkLst>
+        </pc:picChg>
+      </pc:sldChg>
+    </pc:docChg>
+  </pc:docChgLst>
+</pc:chgInfo>
 </file>
 
 <file path=ppt/slideLayouts/slideLayout1.xml><?xml version="1.0" encoding="utf-8"?>
@@ -417,7 +562,7 @@
           <a:p>
             <a:fld id="{B49C5F12-59B6-43D8-97EC-004E96E23D61}" type="datetimeFigureOut">
               <a:rPr lang="en-US" smtClean="0"/>
-              <a:t>9/10/2025</a:t>
+              <a:t>9/10/2026</a:t>
             </a:fld>
             <a:endParaRPr lang="en-US"/>
           </a:p>
@@ -810,7 +955,7 @@
           <a:p>
             <a:fld id="{B49C5F12-59B6-43D8-97EC-004E96E23D61}" type="datetimeFigureOut">
               <a:rPr lang="en-US" smtClean="0"/>
-              <a:t>9/10/2025</a:t>
+              <a:t>9/10/2026</a:t>
             </a:fld>
             <a:endParaRPr lang="en-US"/>
           </a:p>
@@ -1342,7 +1487,7 @@
           <a:p>
             <a:fld id="{B49C5F12-59B6-43D8-97EC-004E96E23D61}" type="datetimeFigureOut">
               <a:rPr lang="en-US" smtClean="0"/>
-              <a:t>9/10/2025</a:t>
+              <a:t>9/10/2026</a:t>
             </a:fld>
             <a:endParaRPr lang="en-US"/>
           </a:p>
@@ -1475,7 +1620,7 @@
           <a:p>
             <a:fld id="{B49C5F12-59B6-43D8-97EC-004E96E23D61}" type="datetimeFigureOut">
               <a:rPr lang="en-US" smtClean="0"/>
-              <a:t>9/10/2025</a:t>
+              <a:t>9/10/2026</a:t>
             </a:fld>
             <a:endParaRPr lang="en-US"/>
           </a:p>
@@ -2018,7 +2163,7 @@
           <a:p>
             <a:fld id="{B49C5F12-59B6-43D8-97EC-004E96E23D61}" type="datetimeFigureOut">
               <a:rPr lang="en-US" smtClean="0"/>
-              <a:t>9/10/2025</a:t>
+              <a:t>9/10/2026</a:t>
             </a:fld>
             <a:endParaRPr lang="en-US"/>
           </a:p>
@@ -2313,7 +2458,7 @@
           <a:p>
             <a:fld id="{B49C5F12-59B6-43D8-97EC-004E96E23D61}" type="datetimeFigureOut">
               <a:rPr lang="en-US" smtClean="0"/>
-              <a:t>9/10/2025</a:t>
+              <a:t>9/10/2026</a:t>
             </a:fld>
             <a:endParaRPr lang="en-US"/>
           </a:p>
@@ -2972,7 +3117,7 @@
           <a:p>
             <a:fld id="{B49C5F12-59B6-43D8-97EC-004E96E23D61}" type="datetimeFigureOut">
               <a:rPr lang="en-US" smtClean="0"/>
-              <a:t>9/10/2025</a:t>
+              <a:t>9/10/2026</a:t>
             </a:fld>
             <a:endParaRPr lang="en-US"/>
           </a:p>
@@ -3408,7 +3553,7 @@
           <a:p>
             <a:fld id="{B49C5F12-59B6-43D8-97EC-004E96E23D61}" type="datetimeFigureOut">
               <a:rPr lang="en-US" smtClean="0"/>
-              <a:t>9/10/2025</a:t>
+              <a:t>9/10/2026</a:t>
             </a:fld>
             <a:endParaRPr lang="en-US"/>
           </a:p>
@@ -3721,7 +3866,7 @@
           <a:p>
             <a:fld id="{B49C5F12-59B6-43D8-97EC-004E96E23D61}" type="datetimeFigureOut">
               <a:rPr lang="en-US" smtClean="0"/>
-              <a:t>9/10/2025</a:t>
+              <a:t>9/10/2026</a:t>
             </a:fld>
             <a:endParaRPr lang="en-US"/>
           </a:p>
@@ -4453,7 +4598,7 @@
           <a:p>
             <a:fld id="{B49C5F12-59B6-43D8-97EC-004E96E23D61}" type="datetimeFigureOut">
               <a:rPr lang="en-US" smtClean="0"/>
-              <a:t>9/10/2025</a:t>
+              <a:t>9/10/2026</a:t>
             </a:fld>
             <a:endParaRPr lang="en-US"/>
           </a:p>
@@ -5117,7 +5262,7 @@
           <a:p>
             <a:fld id="{B49C5F12-59B6-43D8-97EC-004E96E23D61}" type="datetimeFigureOut">
               <a:rPr lang="en-US" smtClean="0"/>
-              <a:t>9/10/2025</a:t>
+              <a:t>9/10/2026</a:t>
             </a:fld>
             <a:endParaRPr lang="en-US"/>
           </a:p>
@@ -5390,7 +5535,7 @@
           <a:p>
             <a:fld id="{B49C5F12-59B6-43D8-97EC-004E96E23D61}" type="datetimeFigureOut">
               <a:rPr lang="en-US" smtClean="0"/>
-              <a:t>9/10/2025</a:t>
+              <a:t>9/10/2026</a:t>
             </a:fld>
             <a:endParaRPr lang="en-US"/>
           </a:p>
@@ -6095,7 +6240,7 @@
             </a:r>
             <a:r>
               <a:rPr lang="en-US" sz="2500" dirty="0"/>
-              <a:t> 25/26</a:t>
+              <a:t> 26/27</a:t>
             </a:r>
           </a:p>
           <a:p>
@@ -6615,10 +6760,10 @@
       </p:grpSpPr>
       <p:pic>
         <p:nvPicPr>
-          <p:cNvPr id="2" name="Imagen 1">
+          <p:cNvPr id="4" name="Imagen 3">
             <a:extLst>
               <a:ext uri="{FF2B5EF4-FFF2-40B4-BE49-F238E27FC236}">
-                <a16:creationId xmlns:a16="http://schemas.microsoft.com/office/drawing/2014/main" id="{F40CDFC2-0D01-40F1-B9F3-67C69E3E47D2}"/>
+                <a16:creationId xmlns:a16="http://schemas.microsoft.com/office/drawing/2014/main" id="{37F48B78-60AB-497B-90C2-5C87950910E1}"/>
               </a:ext>
             </a:extLst>
           </p:cNvPr>
@@ -6635,14 +6780,56 @@
         </p:blipFill>
         <p:spPr>
           <a:xfrm>
-            <a:off x="144614" y="30880"/>
-            <a:ext cx="8985690" cy="6858000"/>
+            <a:off x="499545" y="1628800"/>
+            <a:ext cx="8144909" cy="4596243"/>
           </a:xfrm>
           <a:prstGeom prst="rect">
             <a:avLst/>
           </a:prstGeom>
         </p:spPr>
       </p:pic>
+      <p:sp>
+        <p:nvSpPr>
+          <p:cNvPr id="5" name="1 Título">
+            <a:extLst>
+              <a:ext uri="{FF2B5EF4-FFF2-40B4-BE49-F238E27FC236}">
+                <a16:creationId xmlns:a16="http://schemas.microsoft.com/office/drawing/2014/main" id="{E2FAE8E7-3B75-42DA-8859-49B3B4D97924}"/>
+              </a:ext>
+            </a:extLst>
+          </p:cNvPr>
+          <p:cNvSpPr>
+            <a:spLocks noGrp="1"/>
+          </p:cNvSpPr>
+          <p:nvPr>
+            <p:ph type="title"/>
+          </p:nvPr>
+        </p:nvSpPr>
+        <p:spPr>
+          <a:xfrm>
+            <a:off x="301752" y="228600"/>
+            <a:ext cx="8534400" cy="758952"/>
+          </a:xfrm>
+        </p:spPr>
+        <p:txBody>
+          <a:bodyPr/>
+          <a:lstStyle/>
+          <a:p>
+            <a:r>
+              <a:rPr lang="en-US" dirty="0" err="1"/>
+              <a:t>Guía</a:t>
+            </a:r>
+            <a:r>
+              <a:rPr lang="en-US" dirty="0"/>
+              <a:t> </a:t>
+            </a:r>
+            <a:r>
+              <a:rPr lang="en-US" dirty="0" err="1"/>
+              <a:t>docente</a:t>
+            </a:r>
+            <a:endParaRPr lang="en-US" dirty="0"/>
+          </a:p>
+        </p:txBody>
+      </p:sp>
     </p:spTree>
     <p:extLst>
       <p:ext uri="{BB962C8B-B14F-4D97-AF65-F5344CB8AC3E}">
@@ -7043,10 +7230,10 @@
       </p:sp>
       <p:pic>
         <p:nvPicPr>
-          <p:cNvPr id="3" name="Imagen 2">
+          <p:cNvPr id="6" name="Imagen 5">
             <a:extLst>
               <a:ext uri="{FF2B5EF4-FFF2-40B4-BE49-F238E27FC236}">
-                <a16:creationId xmlns:a16="http://schemas.microsoft.com/office/drawing/2014/main" id="{6A2F4799-A950-4F1C-BC13-02D194CDD79D}"/>
+                <a16:creationId xmlns:a16="http://schemas.microsoft.com/office/drawing/2014/main" id="{3FAE1DC8-9FB2-4AD5-A4E5-4AD5CEB3E9FB}"/>
               </a:ext>
             </a:extLst>
           </p:cNvPr>
@@ -7063,8 +7250,8 @@
         </p:blipFill>
         <p:spPr>
           <a:xfrm>
-            <a:off x="355537" y="2060848"/>
-            <a:ext cx="8450372" cy="3922357"/>
+            <a:off x="217714" y="2132856"/>
+            <a:ext cx="8712222" cy="3921690"/>
           </a:xfrm>
           <a:prstGeom prst="rect">
             <a:avLst/>
@@ -7143,16 +7330,15 @@
           </p:cNvPicPr>
           <p:nvPr/>
         </p:nvPicPr>
-        <p:blipFill>
+        <p:blipFill rotWithShape="1">
           <a:blip r:embed="rId2"/>
-          <a:stretch>
-            <a:fillRect/>
-          </a:stretch>
+          <a:srcRect r="8411" b="41006"/>
+          <a:stretch/>
         </p:blipFill>
         <p:spPr>
           <a:xfrm>
-            <a:off x="971600" y="1124744"/>
-            <a:ext cx="7488832" cy="5220077"/>
+            <a:off x="461225" y="1844824"/>
+            <a:ext cx="8339836" cy="3744416"/>
           </a:xfrm>
           <a:prstGeom prst="rect">
             <a:avLst/>
@@ -7173,6 +7359,288 @@
 </file>
 
 <file path=ppt/slides/slide6.xml><?xml version="1.0" encoding="utf-8"?>
+<p:sld xmlns:a="http://schemas.openxmlformats.org/drawingml/2006/main" xmlns:r="http://schemas.openxmlformats.org/officeDocument/2006/relationships" xmlns:p="http://schemas.openxmlformats.org/presentationml/2006/main">
+  <p:cSld>
+    <p:spTree>
+      <p:nvGrpSpPr>
+        <p:cNvPr id="1" name=""/>
+        <p:cNvGrpSpPr/>
+        <p:nvPr/>
+      </p:nvGrpSpPr>
+      <p:grpSpPr>
+        <a:xfrm>
+          <a:off x="0" y="0"/>
+          <a:ext cx="0" cy="0"/>
+          <a:chOff x="0" y="0"/>
+          <a:chExt cx="0" cy="0"/>
+        </a:xfrm>
+      </p:grpSpPr>
+      <p:sp>
+        <p:nvSpPr>
+          <p:cNvPr id="2" name="Título 1">
+            <a:extLst>
+              <a:ext uri="{FF2B5EF4-FFF2-40B4-BE49-F238E27FC236}">
+                <a16:creationId xmlns:a16="http://schemas.microsoft.com/office/drawing/2014/main" id="{4CE5F88C-C46A-4064-936B-C6E65DA5CB2A}"/>
+              </a:ext>
+            </a:extLst>
+          </p:cNvPr>
+          <p:cNvSpPr>
+            <a:spLocks noGrp="1"/>
+          </p:cNvSpPr>
+          <p:nvPr>
+            <p:ph type="title"/>
+          </p:nvPr>
+        </p:nvSpPr>
+        <p:spPr/>
+        <p:txBody>
+          <a:bodyPr/>
+          <a:lstStyle/>
+          <a:p>
+            <a:r>
+              <a:rPr lang="es-ES" dirty="0"/>
+              <a:t>Planificación detallada</a:t>
+            </a:r>
+          </a:p>
+        </p:txBody>
+      </p:sp>
+      <p:pic>
+        <p:nvPicPr>
+          <p:cNvPr id="3" name="Imagen 2">
+            <a:extLst>
+              <a:ext uri="{FF2B5EF4-FFF2-40B4-BE49-F238E27FC236}">
+                <a16:creationId xmlns:a16="http://schemas.microsoft.com/office/drawing/2014/main" id="{18B6B8DE-C4D2-4FDF-BB6D-D981B0846295}"/>
+              </a:ext>
+            </a:extLst>
+          </p:cNvPr>
+          <p:cNvPicPr>
+            <a:picLocks noChangeAspect="1"/>
+          </p:cNvPicPr>
+          <p:nvPr/>
+        </p:nvPicPr>
+        <p:blipFill rotWithShape="1">
+          <a:blip r:embed="rId2"/>
+          <a:srcRect l="-935" t="60207" r="9646" b="-2554"/>
+          <a:stretch/>
+        </p:blipFill>
+        <p:spPr>
+          <a:xfrm>
+            <a:off x="319602" y="1844824"/>
+            <a:ext cx="8239829" cy="2664296"/>
+          </a:xfrm>
+          <a:prstGeom prst="rect">
+            <a:avLst/>
+          </a:prstGeom>
+        </p:spPr>
+      </p:pic>
+    </p:spTree>
+    <p:extLst>
+      <p:ext uri="{BB962C8B-B14F-4D97-AF65-F5344CB8AC3E}">
+        <p14:creationId xmlns:p14="http://schemas.microsoft.com/office/powerpoint/2010/main" val="4022057110"/>
+      </p:ext>
+    </p:extLst>
+  </p:cSld>
+  <p:clrMapOvr>
+    <a:masterClrMapping/>
+  </p:clrMapOvr>
+</p:sld>
+</file>
+
+<file path=ppt/slides/slide7.xml><?xml version="1.0" encoding="utf-8"?>
+<p:sld xmlns:a="http://schemas.openxmlformats.org/drawingml/2006/main" xmlns:r="http://schemas.openxmlformats.org/officeDocument/2006/relationships" xmlns:p="http://schemas.openxmlformats.org/presentationml/2006/main">
+  <p:cSld>
+    <p:spTree>
+      <p:nvGrpSpPr>
+        <p:cNvPr id="1" name=""/>
+        <p:cNvGrpSpPr/>
+        <p:nvPr/>
+      </p:nvGrpSpPr>
+      <p:grpSpPr>
+        <a:xfrm>
+          <a:off x="0" y="0"/>
+          <a:ext cx="0" cy="0"/>
+          <a:chOff x="0" y="0"/>
+          <a:chExt cx="0" cy="0"/>
+        </a:xfrm>
+      </p:grpSpPr>
+      <p:sp>
+        <p:nvSpPr>
+          <p:cNvPr id="2" name="Título 1">
+            <a:extLst>
+              <a:ext uri="{FF2B5EF4-FFF2-40B4-BE49-F238E27FC236}">
+                <a16:creationId xmlns:a16="http://schemas.microsoft.com/office/drawing/2014/main" id="{44CD1AC7-1036-4631-96D7-3915C8D3A0B3}"/>
+              </a:ext>
+            </a:extLst>
+          </p:cNvPr>
+          <p:cNvSpPr>
+            <a:spLocks noGrp="1"/>
+          </p:cNvSpPr>
+          <p:nvPr>
+            <p:ph type="title"/>
+          </p:nvPr>
+        </p:nvSpPr>
+        <p:spPr/>
+        <p:txBody>
+          <a:bodyPr/>
+          <a:lstStyle/>
+          <a:p>
+            <a:r>
+              <a:rPr lang="es-ES" dirty="0"/>
+              <a:t>Herramientas</a:t>
+            </a:r>
+          </a:p>
+        </p:txBody>
+      </p:sp>
+      <p:sp>
+        <p:nvSpPr>
+          <p:cNvPr id="3" name="Marcador de contenido 2">
+            <a:extLst>
+              <a:ext uri="{FF2B5EF4-FFF2-40B4-BE49-F238E27FC236}">
+                <a16:creationId xmlns:a16="http://schemas.microsoft.com/office/drawing/2014/main" id="{FB128483-14E0-419D-A99C-5B612375638C}"/>
+              </a:ext>
+            </a:extLst>
+          </p:cNvPr>
+          <p:cNvSpPr>
+            <a:spLocks noGrp="1"/>
+          </p:cNvSpPr>
+          <p:nvPr>
+            <p:ph sz="quarter" idx="1"/>
+          </p:nvPr>
+        </p:nvSpPr>
+        <p:spPr/>
+        <p:txBody>
+          <a:bodyPr>
+            <a:normAutofit/>
+          </a:bodyPr>
+          <a:lstStyle/>
+          <a:p>
+            <a:r>
+              <a:rPr lang="es-ES" sz="2400" dirty="0"/>
+              <a:t>Lenguajes: C, C++, C#, </a:t>
+            </a:r>
+            <a:r>
+              <a:rPr lang="es-ES" sz="2400" dirty="0" err="1"/>
+              <a:t>Kotlin</a:t>
+            </a:r>
+            <a:r>
+              <a:rPr lang="es-ES" sz="2400" dirty="0"/>
+              <a:t>, Python</a:t>
+            </a:r>
+          </a:p>
+          <a:p>
+            <a:r>
+              <a:rPr lang="es-ES" sz="2400" dirty="0"/>
+              <a:t>Desarrollo de código: </a:t>
+            </a:r>
+            <a:r>
+              <a:rPr lang="es-ES" sz="2400" dirty="0" err="1"/>
+              <a:t>git</a:t>
+            </a:r>
+            <a:r>
+              <a:rPr lang="es-ES" sz="2400" dirty="0"/>
+              <a:t>, </a:t>
+            </a:r>
+            <a:r>
+              <a:rPr lang="es-ES" sz="2400" dirty="0" err="1"/>
+              <a:t>vscode</a:t>
+            </a:r>
+            <a:r>
+              <a:rPr lang="es-ES" sz="2400" dirty="0"/>
+              <a:t>, </a:t>
+            </a:r>
+            <a:r>
+              <a:rPr lang="es-ES" sz="2400" dirty="0" err="1"/>
+              <a:t>copilot</a:t>
+            </a:r>
+            <a:endParaRPr lang="es-ES" sz="2400" dirty="0"/>
+          </a:p>
+          <a:p>
+            <a:r>
+              <a:rPr lang="es-ES" sz="2400" dirty="0"/>
+              <a:t>Arquitecturas IoT: </a:t>
+            </a:r>
+            <a:r>
+              <a:rPr lang="es-ES" sz="2400" dirty="0" err="1"/>
+              <a:t>mqtt</a:t>
+            </a:r>
+            <a:r>
+              <a:rPr lang="es-ES" sz="2400" dirty="0"/>
+              <a:t>, n8n</a:t>
+            </a:r>
+          </a:p>
+          <a:p>
+            <a:r>
+              <a:rPr lang="es-ES" sz="2400" dirty="0"/>
+              <a:t>Arquitecturas móviles: Android</a:t>
+            </a:r>
+          </a:p>
+          <a:p>
+            <a:r>
+              <a:rPr lang="es-ES" sz="2400" dirty="0"/>
+              <a:t>Desarrollo web: </a:t>
+            </a:r>
+            <a:r>
+              <a:rPr lang="es-ES" sz="2400" dirty="0" err="1"/>
+              <a:t>php</a:t>
+            </a:r>
+            <a:r>
+              <a:rPr lang="es-ES" sz="2400" dirty="0"/>
+              <a:t>, </a:t>
+            </a:r>
+            <a:r>
+              <a:rPr lang="es-ES" sz="2400" dirty="0" err="1"/>
+              <a:t>javascript</a:t>
+            </a:r>
+            <a:endParaRPr lang="es-ES" sz="2400" dirty="0"/>
+          </a:p>
+          <a:p>
+            <a:r>
+              <a:rPr lang="es-ES" sz="2400" dirty="0"/>
+              <a:t>Microcontroladores basados en arquitecturas </a:t>
+            </a:r>
+            <a:r>
+              <a:rPr lang="es-ES" sz="2400" dirty="0" err="1"/>
+              <a:t>RiscV</a:t>
+            </a:r>
+            <a:endParaRPr lang="es-ES" sz="2400" dirty="0"/>
+          </a:p>
+          <a:p>
+            <a:r>
+              <a:rPr lang="es-ES" sz="2400" dirty="0"/>
+              <a:t>Placas de desarrollo y </a:t>
+            </a:r>
+            <a:r>
+              <a:rPr lang="es-ES" sz="2400" dirty="0" err="1"/>
+              <a:t>perfboards</a:t>
+            </a:r>
+            <a:endParaRPr lang="es-ES" sz="2400" dirty="0"/>
+          </a:p>
+          <a:p>
+            <a:r>
+              <a:rPr lang="es-ES" sz="2400" dirty="0"/>
+              <a:t>Comunicaciones: Wifi, Bluetooth, BLE, </a:t>
+            </a:r>
+            <a:r>
+              <a:rPr lang="es-ES" sz="2400" dirty="0" err="1"/>
+              <a:t>LoRa</a:t>
+            </a:r>
+            <a:endParaRPr lang="es-ES" sz="2400" dirty="0"/>
+          </a:p>
+        </p:txBody>
+      </p:sp>
+    </p:spTree>
+    <p:extLst>
+      <p:ext uri="{BB962C8B-B14F-4D97-AF65-F5344CB8AC3E}">
+        <p14:creationId xmlns:p14="http://schemas.microsoft.com/office/powerpoint/2010/main" val="1495471381"/>
+      </p:ext>
+    </p:extLst>
+  </p:cSld>
+  <p:clrMapOvr>
+    <a:masterClrMapping/>
+  </p:clrMapOvr>
+</p:sld>
+</file>
+
+<file path=ppt/slides/slide8.xml><?xml version="1.0" encoding="utf-8"?>
 <p:sld xmlns:a="http://schemas.openxmlformats.org/drawingml/2006/main" xmlns:r="http://schemas.openxmlformats.org/officeDocument/2006/relationships" xmlns:p="http://schemas.openxmlformats.org/presentationml/2006/main">
   <p:cSld>
     <p:spTree>
@@ -7254,7 +7722,7 @@
 </p:sld>
 </file>
 
-<file path=ppt/slides/slide7.xml><?xml version="1.0" encoding="utf-8"?>
+<file path=ppt/slides/slide9.xml><?xml version="1.0" encoding="utf-8"?>
 <p:sld xmlns:a="http://schemas.openxmlformats.org/drawingml/2006/main" xmlns:r="http://schemas.openxmlformats.org/officeDocument/2006/relationships" xmlns:p="http://schemas.openxmlformats.org/presentationml/2006/main">
   <p:cSld>
     <p:spTree>
@@ -7397,7 +7865,7 @@
               <a:rPr lang="es-ES" dirty="0">
                 <a:hlinkClick r:id="rId2"/>
               </a:rPr>
-              <a:t>https://eii.cv.uma.es/course/view.php?id=5713</a:t>
+              <a:t>https://eii.cv.uma.es/course/view.php?id=193</a:t>
             </a:r>
             <a:endParaRPr lang="es-ES" dirty="0"/>
           </a:p>
@@ -7407,11 +7875,11 @@
               <a:rPr lang="es-ES" dirty="0">
                 <a:hlinkClick r:id="rId3"/>
               </a:rPr>
-              <a:t>https://github.com/luisfromero/ac</a:t>
+              <a:t>https://github.com/luisfromero/arqcom</a:t>
             </a:r>
             <a:r>
               <a:rPr lang="es-ES" dirty="0"/>
-              <a:t> (requiere invitación)</a:t>
+              <a:t> </a:t>
             </a:r>
           </a:p>
           <a:p>
@@ -7444,7 +7912,7 @@
             </a:r>
             <a:r>
               <a:rPr lang="en-US" dirty="0"/>
-              <a:t>)</a:t>
+              <a:t>, 656358240)</a:t>
             </a:r>
           </a:p>
           <a:p>
@@ -7768,6 +8236,12 @@
 </file>
 
 <file path=customXml/item2.xml><?xml version="1.0" encoding="utf-8"?>
+<p:properties xmlns:p="http://schemas.microsoft.com/office/2006/metadata/properties" xmlns:xsi="http://www.w3.org/2001/XMLSchema-instance" xmlns:pc="http://schemas.microsoft.com/office/infopath/2007/PartnerControls">
+  <documentManagement/>
+</p:properties>
+</file>
+
+<file path=customXml/item3.xml><?xml version="1.0" encoding="utf-8"?>
 <ct:contentTypeSchema xmlns:ct="http://schemas.microsoft.com/office/2006/metadata/contentType" xmlns:ma="http://schemas.microsoft.com/office/2006/metadata/properties/metaAttributes" ct:_="" ma:_="" ma:contentTypeName="Documento" ma:contentTypeID="0x0101004CE8D363D1A06C4A8E99892E111062E1" ma:contentTypeVersion="11" ma:contentTypeDescription="Crear nuevo documento." ma:contentTypeScope="" ma:versionID="bc7335ac6b45c3b24761353ffdff9b7a">
   <xsd:schema xmlns:xsd="http://www.w3.org/2001/XMLSchema" xmlns:xs="http://www.w3.org/2001/XMLSchema" xmlns:p="http://schemas.microsoft.com/office/2006/metadata/properties" xmlns:ns3="2d68f367-3448-4584-8be4-e5200f1a88eb" xmlns:ns4="b7216d0d-3061-4c5f-91f9-f9dbb705efc2" targetNamespace="http://schemas.microsoft.com/office/2006/metadata/properties" ma:root="true" ma:fieldsID="9890ec198a05d4ef84ee45e003419e1e" ns3:_="" ns4:_="">
     <xsd:import namespace="2d68f367-3448-4584-8be4-e5200f1a88eb"/>
@@ -7976,12 +8450,6 @@
 </ct:contentTypeSchema>
 </file>
 
-<file path=customXml/item3.xml><?xml version="1.0" encoding="utf-8"?>
-<p:properties xmlns:p="http://schemas.microsoft.com/office/2006/metadata/properties" xmlns:xsi="http://www.w3.org/2001/XMLSchema-instance" xmlns:pc="http://schemas.microsoft.com/office/infopath/2007/PartnerControls">
-  <documentManagement/>
-</p:properties>
-</file>
-
 <file path=customXml/itemProps1.xml><?xml version="1.0" encoding="utf-8"?>
 <ds:datastoreItem xmlns:ds="http://schemas.openxmlformats.org/officeDocument/2006/customXml" ds:itemID="{B9A8E0AA-B776-4AB2-BDEB-3AFAC6847E8B}">
   <ds:schemaRefs>
@@ -7991,6 +8459,23 @@
 </file>
 
 <file path=customXml/itemProps2.xml><?xml version="1.0" encoding="utf-8"?>
+<ds:datastoreItem xmlns:ds="http://schemas.openxmlformats.org/officeDocument/2006/customXml" ds:itemID="{1DE7AE15-D3B5-418C-AB01-AAE87B4DC314}">
+  <ds:schemaRefs>
+    <ds:schemaRef ds:uri="http://www.w3.org/XML/1998/namespace"/>
+    <ds:schemaRef ds:uri="http://purl.org/dc/elements/1.1/"/>
+    <ds:schemaRef ds:uri="b7216d0d-3061-4c5f-91f9-f9dbb705efc2"/>
+    <ds:schemaRef ds:uri="http://schemas.microsoft.com/office/2006/documentManagement/types"/>
+    <ds:schemaRef ds:uri="http://purl.org/dc/terms/"/>
+    <ds:schemaRef ds:uri="http://schemas.microsoft.com/office/infopath/2007/PartnerControls"/>
+    <ds:schemaRef ds:uri="http://purl.org/dc/dcmitype/"/>
+    <ds:schemaRef ds:uri="http://schemas.openxmlformats.org/package/2006/metadata/core-properties"/>
+    <ds:schemaRef ds:uri="2d68f367-3448-4584-8be4-e5200f1a88eb"/>
+    <ds:schemaRef ds:uri="http://schemas.microsoft.com/office/2006/metadata/properties"/>
+  </ds:schemaRefs>
+</ds:datastoreItem>
+</file>
+
+<file path=customXml/itemProps3.xml><?xml version="1.0" encoding="utf-8"?>
 <ds:datastoreItem xmlns:ds="http://schemas.openxmlformats.org/officeDocument/2006/customXml" ds:itemID="{0B4BF2B3-C642-4EE1-807E-EFF9AA359007}">
   <ds:schemaRefs>
     <ds:schemaRef ds:uri="http://schemas.microsoft.com/office/2006/metadata/contentType"/>
@@ -8007,21 +8492,4 @@
     <ds:schemaRef ds:uri="http://schemas.microsoft.com/internal/obd"/>
   </ds:schemaRefs>
 </ds:datastoreItem>
-</file>
-
-<file path=customXml/itemProps3.xml><?xml version="1.0" encoding="utf-8"?>
-<ds:datastoreItem xmlns:ds="http://schemas.openxmlformats.org/officeDocument/2006/customXml" ds:itemID="{1DE7AE15-D3B5-418C-AB01-AAE87B4DC314}">
-  <ds:schemaRefs>
-    <ds:schemaRef ds:uri="http://www.w3.org/XML/1998/namespace"/>
-    <ds:schemaRef ds:uri="http://purl.org/dc/elements/1.1/"/>
-    <ds:schemaRef ds:uri="b7216d0d-3061-4c5f-91f9-f9dbb705efc2"/>
-    <ds:schemaRef ds:uri="http://schemas.microsoft.com/office/2006/documentManagement/types"/>
-    <ds:schemaRef ds:uri="http://purl.org/dc/terms/"/>
-    <ds:schemaRef ds:uri="http://schemas.microsoft.com/office/infopath/2007/PartnerControls"/>
-    <ds:schemaRef ds:uri="http://purl.org/dc/dcmitype/"/>
-    <ds:schemaRef ds:uri="http://schemas.openxmlformats.org/package/2006/metadata/core-properties"/>
-    <ds:schemaRef ds:uri="2d68f367-3448-4584-8be4-e5200f1a88eb"/>
-    <ds:schemaRef ds:uri="http://schemas.microsoft.com/office/2006/metadata/properties"/>
-  </ds:schemaRefs>
-</ds:datastoreItem>
 </file>
</xml_diff>